<commit_message>
Updated Github Link in PPT
</commit_message>
<xml_diff>
--- a/AuditGuard Excel Dashboard Presentation.pptx
+++ b/AuditGuard Excel Dashboard Presentation.pptx
@@ -237,7 +237,7 @@
           <a:p>
             <a:fld id="{CDA3C146-E2BA-41EA-8AE9-0C67692768F2}" type="datetimeFigureOut">
               <a:rPr lang="en-US" smtClean="0"/>
-              <a:t>4/12/2025</a:t>
+              <a:t>4/14/2025</a:t>
             </a:fld>
             <a:endParaRPr lang="en-US" dirty="0"/>
           </a:p>
@@ -414,7 +414,7 @@
           <a:p>
             <a:fld id="{1F7D3EB6-8099-4744-9273-C8C1DD61A2EA}" type="datetimeFigureOut">
               <a:rPr lang="en-US" noProof="0" smtClean="0"/>
-              <a:t>4/12/2025</a:t>
+              <a:t>4/14/2025</a:t>
             </a:fld>
             <a:endParaRPr lang="en-US" noProof="0" dirty="0"/>
           </a:p>
@@ -29123,7 +29123,7 @@
             <a:blip r:embed="rId2">
               <a:extLst>
                 <a:ext uri="{96DAC541-7B7A-43D3-8B79-37D633B846F1}">
-                  <asvg:svgBlip xmlns="" xmlns:asvg="http://schemas.microsoft.com/office/drawing/2016/SVG/main" r:embed="rId3"/>
+                  <asvg:svgBlip xmlns:asvg="http://schemas.microsoft.com/office/drawing/2016/SVG/main" xmlns="" r:embed="rId3"/>
                 </a:ext>
               </a:extLst>
             </a:blip>
@@ -39785,7 +39785,7 @@
             <a:blip r:embed="rId2">
               <a:extLst>
                 <a:ext uri="{96DAC541-7B7A-43D3-8B79-37D633B846F1}">
-                  <asvg:svgBlip xmlns="" xmlns:asvg="http://schemas.microsoft.com/office/drawing/2016/SVG/main" r:embed="rId3"/>
+                  <asvg:svgBlip xmlns:asvg="http://schemas.microsoft.com/office/drawing/2016/SVG/main" xmlns="" r:embed="rId3"/>
                 </a:ext>
               </a:extLst>
             </a:blip>
@@ -43892,11 +43892,7 @@
           <a:p>
             <a:r>
               <a:rPr lang="en-US" dirty="0" smtClean="0"/>
-              <a:t>AuditGuard: Excel </a:t>
-            </a:r>
-            <a:r>
-              <a:rPr lang="en-US" dirty="0" smtClean="0"/>
-              <a:t>Dashboard</a:t>
+              <a:t>AuditGuard: Excel Dashboard</a:t>
             </a:r>
             <a:endParaRPr lang="ru-RU" dirty="0"/>
           </a:p>
@@ -44134,14 +44130,7 @@
                 <a:latin typeface="Times New Roman" panose="02020603050405020304" pitchFamily="18" charset="0"/>
                 <a:cs typeface="Times New Roman" panose="02020603050405020304" pitchFamily="18" charset="0"/>
               </a:rPr>
-              <a:t>Data </a:t>
-            </a:r>
-            <a:r>
-              <a:rPr lang="en-US" dirty="0" smtClean="0">
-                <a:latin typeface="Times New Roman" panose="02020603050405020304" pitchFamily="18" charset="0"/>
-                <a:cs typeface="Times New Roman" panose="02020603050405020304" pitchFamily="18" charset="0"/>
-              </a:rPr>
-              <a:t>Analytics</a:t>
+              <a:t>Data Analytics</a:t>
             </a:r>
           </a:p>
           <a:p>
@@ -46064,11 +46053,6 @@
               </a:rPr>
               <a:t>: Data Cleaning and Transformation</a:t>
             </a:r>
-            <a:endParaRPr lang="en-US" sz="1300" dirty="0" smtClean="0">
-              <a:solidFill>
-                <a:schemeClr val="bg2"/>
-              </a:solidFill>
-            </a:endParaRPr>
           </a:p>
           <a:p>
             <a:pPr>
@@ -46107,11 +46091,6 @@
               </a:rPr>
               <a:t>Creating New Measures</a:t>
             </a:r>
-            <a:endParaRPr lang="en-US" sz="1300" dirty="0" smtClean="0">
-              <a:solidFill>
-                <a:schemeClr val="bg2"/>
-              </a:solidFill>
-            </a:endParaRPr>
           </a:p>
           <a:p>
             <a:pPr>
@@ -47232,42 +47211,9 @@
           <a:p>
             <a:r>
               <a:rPr lang="en-US" dirty="0" smtClean="0"/>
-              <a:t>GitHub:</a:t>
+              <a:t>GitHub Repository Link:</a:t>
             </a:r>
             <a:endParaRPr lang="ru-RU" dirty="0"/>
-          </a:p>
-        </p:txBody>
-      </p:sp>
-      <p:sp>
-        <p:nvSpPr>
-          <p:cNvPr id="13" name="Text Placeholder 12">
-            <a:extLst>
-              <a:ext uri="{FF2B5EF4-FFF2-40B4-BE49-F238E27FC236}">
-                <a16:creationId xmlns:a16="http://schemas.microsoft.com/office/drawing/2014/main" id="{D55212BC-6862-4B56-B856-7A97BBD3D4F1}"/>
-              </a:ext>
-            </a:extLst>
-          </p:cNvPr>
-          <p:cNvSpPr>
-            <a:spLocks noGrp="1"/>
-          </p:cNvSpPr>
-          <p:nvPr>
-            <p:ph type="body" sz="quarter" idx="21"/>
-          </p:nvPr>
-        </p:nvSpPr>
-        <p:spPr/>
-        <p:txBody>
-          <a:bodyPr/>
-          <a:lstStyle/>
-          <a:p>
-            <a:r>
-              <a:rPr lang="en-US" dirty="0"/>
-              <a:t>http://</a:t>
-            </a:r>
-            <a:r>
-              <a:rPr lang="en-US" dirty="0" smtClean="0"/>
-              <a:t>www.github/BillyTevin11</a:t>
-            </a:r>
-            <a:endParaRPr lang="en-US" dirty="0"/>
           </a:p>
         </p:txBody>
       </p:sp>
@@ -47302,6 +47248,208 @@
         </p:blipFill>
         <p:spPr/>
       </p:pic>
+      <p:sp>
+        <p:nvSpPr>
+          <p:cNvPr id="14" name="Text Placeholder 12">
+            <a:extLst>
+              <a:ext uri="{FF2B5EF4-FFF2-40B4-BE49-F238E27FC236}">
+                <a16:creationId xmlns:a16="http://schemas.microsoft.com/office/drawing/2014/main" id="{D55212BC-6862-4B56-B856-7A97BBD3D4F1}"/>
+              </a:ext>
+            </a:extLst>
+          </p:cNvPr>
+          <p:cNvSpPr txBox="1">
+            <a:spLocks/>
+          </p:cNvSpPr>
+          <p:nvPr/>
+        </p:nvSpPr>
+        <p:spPr>
+          <a:xfrm>
+            <a:off x="768236" y="5521727"/>
+            <a:ext cx="4656802" cy="1027354"/>
+          </a:xfrm>
+          <a:prstGeom prst="rect">
+            <a:avLst/>
+          </a:prstGeom>
+        </p:spPr>
+        <p:txBody>
+          <a:bodyPr vert="horz" lIns="0" tIns="0" rIns="0" bIns="0" rtlCol="0">
+            <a:noAutofit/>
+          </a:bodyPr>
+          <a:lstStyle>
+            <a:lvl1pPr marL="0" indent="0" algn="l" defTabSz="914400" rtl="0" eaLnBrk="1" latinLnBrk="0" hangingPunct="1">
+              <a:lnSpc>
+                <a:spcPct val="90000"/>
+              </a:lnSpc>
+              <a:spcBef>
+                <a:spcPts val="1000"/>
+              </a:spcBef>
+              <a:buFont typeface="Arial" panose="020B0604020202020204" pitchFamily="34" charset="0"/>
+              <a:buNone/>
+              <a:defRPr sz="2000" b="1" kern="1200">
+                <a:solidFill>
+                  <a:schemeClr val="bg2"/>
+                </a:solidFill>
+                <a:latin typeface="+mj-lt"/>
+                <a:ea typeface="+mn-ea"/>
+                <a:cs typeface="+mn-cs"/>
+              </a:defRPr>
+            </a:lvl1pPr>
+            <a:lvl2pPr marL="457200" indent="0" algn="l" defTabSz="914400" rtl="0" eaLnBrk="1" latinLnBrk="0" hangingPunct="1">
+              <a:lnSpc>
+                <a:spcPct val="90000"/>
+              </a:lnSpc>
+              <a:spcBef>
+                <a:spcPts val="500"/>
+              </a:spcBef>
+              <a:buFont typeface="Arial" panose="020B0604020202020204" pitchFamily="34" charset="0"/>
+              <a:buNone/>
+              <a:defRPr sz="3600" b="1" kern="1200">
+                <a:solidFill>
+                  <a:schemeClr val="bg2"/>
+                </a:solidFill>
+                <a:latin typeface="+mj-lt"/>
+                <a:ea typeface="+mn-ea"/>
+                <a:cs typeface="+mn-cs"/>
+              </a:defRPr>
+            </a:lvl2pPr>
+            <a:lvl3pPr marL="914400" indent="0" algn="l" defTabSz="914400" rtl="0" eaLnBrk="1" latinLnBrk="0" hangingPunct="1">
+              <a:lnSpc>
+                <a:spcPct val="90000"/>
+              </a:lnSpc>
+              <a:spcBef>
+                <a:spcPts val="500"/>
+              </a:spcBef>
+              <a:buFont typeface="Arial" panose="020B0604020202020204" pitchFamily="34" charset="0"/>
+              <a:buNone/>
+              <a:defRPr sz="3600" b="1" kern="1200">
+                <a:solidFill>
+                  <a:schemeClr val="bg2"/>
+                </a:solidFill>
+                <a:latin typeface="+mj-lt"/>
+                <a:ea typeface="+mn-ea"/>
+                <a:cs typeface="+mn-cs"/>
+              </a:defRPr>
+            </a:lvl3pPr>
+            <a:lvl4pPr marL="1371600" indent="0" algn="l" defTabSz="914400" rtl="0" eaLnBrk="1" latinLnBrk="0" hangingPunct="1">
+              <a:lnSpc>
+                <a:spcPct val="90000"/>
+              </a:lnSpc>
+              <a:spcBef>
+                <a:spcPts val="500"/>
+              </a:spcBef>
+              <a:buFont typeface="Arial" panose="020B0604020202020204" pitchFamily="34" charset="0"/>
+              <a:buNone/>
+              <a:defRPr sz="3600" b="1" kern="1200">
+                <a:solidFill>
+                  <a:schemeClr val="bg2"/>
+                </a:solidFill>
+                <a:latin typeface="+mj-lt"/>
+                <a:ea typeface="+mn-ea"/>
+                <a:cs typeface="+mn-cs"/>
+              </a:defRPr>
+            </a:lvl4pPr>
+            <a:lvl5pPr marL="1828800" indent="0" algn="l" defTabSz="914400" rtl="0" eaLnBrk="1" latinLnBrk="0" hangingPunct="1">
+              <a:lnSpc>
+                <a:spcPct val="90000"/>
+              </a:lnSpc>
+              <a:spcBef>
+                <a:spcPts val="500"/>
+              </a:spcBef>
+              <a:buFont typeface="Arial" panose="020B0604020202020204" pitchFamily="34" charset="0"/>
+              <a:buNone/>
+              <a:defRPr sz="3600" b="1" kern="1200">
+                <a:solidFill>
+                  <a:schemeClr val="bg2"/>
+                </a:solidFill>
+                <a:latin typeface="+mj-lt"/>
+                <a:ea typeface="+mn-ea"/>
+                <a:cs typeface="+mn-cs"/>
+              </a:defRPr>
+            </a:lvl5pPr>
+            <a:lvl6pPr marL="2514600" indent="-228600" algn="l" defTabSz="914400" rtl="0" eaLnBrk="1" latinLnBrk="0" hangingPunct="1">
+              <a:lnSpc>
+                <a:spcPct val="90000"/>
+              </a:lnSpc>
+              <a:spcBef>
+                <a:spcPts val="500"/>
+              </a:spcBef>
+              <a:buFont typeface="Arial" panose="020B0604020202020204" pitchFamily="34" charset="0"/>
+              <a:buChar char="•"/>
+              <a:defRPr sz="1800" kern="1200">
+                <a:solidFill>
+                  <a:schemeClr val="tx1"/>
+                </a:solidFill>
+                <a:latin typeface="+mn-lt"/>
+                <a:ea typeface="+mn-ea"/>
+                <a:cs typeface="+mn-cs"/>
+              </a:defRPr>
+            </a:lvl6pPr>
+            <a:lvl7pPr marL="2971800" indent="-228600" algn="l" defTabSz="914400" rtl="0" eaLnBrk="1" latinLnBrk="0" hangingPunct="1">
+              <a:lnSpc>
+                <a:spcPct val="90000"/>
+              </a:lnSpc>
+              <a:spcBef>
+                <a:spcPts val="500"/>
+              </a:spcBef>
+              <a:buFont typeface="Arial" panose="020B0604020202020204" pitchFamily="34" charset="0"/>
+              <a:buChar char="•"/>
+              <a:defRPr sz="1800" kern="1200">
+                <a:solidFill>
+                  <a:schemeClr val="tx1"/>
+                </a:solidFill>
+                <a:latin typeface="+mn-lt"/>
+                <a:ea typeface="+mn-ea"/>
+                <a:cs typeface="+mn-cs"/>
+              </a:defRPr>
+            </a:lvl7pPr>
+            <a:lvl8pPr marL="3429000" indent="-228600" algn="l" defTabSz="914400" rtl="0" eaLnBrk="1" latinLnBrk="0" hangingPunct="1">
+              <a:lnSpc>
+                <a:spcPct val="90000"/>
+              </a:lnSpc>
+              <a:spcBef>
+                <a:spcPts val="500"/>
+              </a:spcBef>
+              <a:buFont typeface="Arial" panose="020B0604020202020204" pitchFamily="34" charset="0"/>
+              <a:buChar char="•"/>
+              <a:defRPr sz="1800" kern="1200">
+                <a:solidFill>
+                  <a:schemeClr val="tx1"/>
+                </a:solidFill>
+                <a:latin typeface="+mn-lt"/>
+                <a:ea typeface="+mn-ea"/>
+                <a:cs typeface="+mn-cs"/>
+              </a:defRPr>
+            </a:lvl8pPr>
+            <a:lvl9pPr marL="3886200" indent="-228600" algn="l" defTabSz="914400" rtl="0" eaLnBrk="1" latinLnBrk="0" hangingPunct="1">
+              <a:lnSpc>
+                <a:spcPct val="90000"/>
+              </a:lnSpc>
+              <a:spcBef>
+                <a:spcPts val="500"/>
+              </a:spcBef>
+              <a:buFont typeface="Arial" panose="020B0604020202020204" pitchFamily="34" charset="0"/>
+              <a:buChar char="•"/>
+              <a:defRPr sz="1800" kern="1200">
+                <a:solidFill>
+                  <a:schemeClr val="tx1"/>
+                </a:solidFill>
+                <a:latin typeface="+mn-lt"/>
+                <a:ea typeface="+mn-ea"/>
+                <a:cs typeface="+mn-cs"/>
+              </a:defRPr>
+            </a:lvl9pPr>
+          </a:lstStyle>
+          <a:p>
+            <a:r>
+              <a:rPr lang="en-US" dirty="0" smtClean="0">
+                <a:hlinkClick r:id="rId3"/>
+              </a:rPr>
+              <a:t>github.com/BillyTevin11/AuditGuard-Big-4-Risk-and-Compliance-Insights</a:t>
+            </a:r>
+            <a:endParaRPr lang="en-US" dirty="0"/>
+          </a:p>
+        </p:txBody>
+      </p:sp>
     </p:spTree>
     <p:extLst>
       <p:ext uri="{BB962C8B-B14F-4D97-AF65-F5344CB8AC3E}">
@@ -48152,6 +48300,23 @@
 </file>
 
 <file path=customXml/item1.xml><?xml version="1.0" encoding="utf-8"?>
+<p:properties xmlns:p="http://schemas.microsoft.com/office/2006/metadata/properties" xmlns:xsi="http://www.w3.org/2001/XMLSchema-instance" xmlns:pc="http://schemas.microsoft.com/office/infopath/2007/PartnerControls">
+  <documentManagement>
+    <MediaServiceKeyPoints xmlns="71af3243-3dd4-4a8d-8c0d-dd76da1f02a5" xsi:nil="true"/>
+  </documentManagement>
+</p:properties>
+</file>
+
+<file path=customXml/item2.xml><?xml version="1.0" encoding="utf-8"?>
+<?mso-contentType ?>
+<FormTemplates xmlns="http://schemas.microsoft.com/sharepoint/v3/contenttype/forms">
+  <Display>DocumentLibraryForm</Display>
+  <Edit>DocumentLibraryForm</Edit>
+  <New>DocumentLibraryForm</New>
+</FormTemplates>
+</file>
+
+<file path=customXml/item3.xml><?xml version="1.0" encoding="utf-8"?>
 <ct:contentTypeSchema xmlns:ct="http://schemas.microsoft.com/office/2006/metadata/contentType" xmlns:ma="http://schemas.microsoft.com/office/2006/metadata/properties/metaAttributes" ct:_="" ma:_="" ma:contentTypeName="Document" ma:contentTypeID="0x01010079F111ED35F8CC479449609E8A0923A6" ma:contentTypeVersion="11" ma:contentTypeDescription="Create a new document." ma:contentTypeScope="" ma:versionID="96291512c1ee715ab617f4c07df79fc1">
   <xsd:schema xmlns:xsd="http://www.w3.org/2001/XMLSchema" xmlns:xs="http://www.w3.org/2001/XMLSchema" xmlns:p="http://schemas.microsoft.com/office/2006/metadata/properties" xmlns:ns2="71af3243-3dd4-4a8d-8c0d-dd76da1f02a5" xmlns:ns3="16c05727-aa75-4e4a-9b5f-8a80a1165891" targetNamespace="http://schemas.microsoft.com/office/2006/metadata/properties" ma:root="true" ma:fieldsID="8256c27c40ca5c40ce1cf6c44f0205df" ns2:_="" ns3:_="">
     <xsd:import namespace="71af3243-3dd4-4a8d-8c0d-dd76da1f02a5"/>
@@ -48362,24 +48527,25 @@
 </ct:contentTypeSchema>
 </file>
 
-<file path=customXml/item2.xml><?xml version="1.0" encoding="utf-8"?>
-<?mso-contentType ?>
-<FormTemplates xmlns="http://schemas.microsoft.com/sharepoint/v3/contenttype/forms">
-  <Display>DocumentLibraryForm</Display>
-  <Edit>DocumentLibraryForm</Edit>
-  <New>DocumentLibraryForm</New>
-</FormTemplates>
+<file path=customXml/itemProps1.xml><?xml version="1.0" encoding="utf-8"?>
+<ds:datastoreItem xmlns:ds="http://schemas.openxmlformats.org/officeDocument/2006/customXml" ds:itemID="{D726A944-A9F4-4295-9B5E-C397EB1318B9}">
+  <ds:schemaRefs>
+    <ds:schemaRef ds:uri="http://schemas.microsoft.com/office/2006/metadata/properties"/>
+    <ds:schemaRef ds:uri="http://schemas.microsoft.com/office/infopath/2007/PartnerControls"/>
+    <ds:schemaRef ds:uri="71af3243-3dd4-4a8d-8c0d-dd76da1f02a5"/>
+  </ds:schemaRefs>
+</ds:datastoreItem>
 </file>
 
-<file path=customXml/item3.xml><?xml version="1.0" encoding="utf-8"?>
-<p:properties xmlns:p="http://schemas.microsoft.com/office/2006/metadata/properties" xmlns:xsi="http://www.w3.org/2001/XMLSchema-instance" xmlns:pc="http://schemas.microsoft.com/office/infopath/2007/PartnerControls">
-  <documentManagement>
-    <MediaServiceKeyPoints xmlns="71af3243-3dd4-4a8d-8c0d-dd76da1f02a5" xsi:nil="true"/>
-  </documentManagement>
-</p:properties>
+<file path=customXml/itemProps2.xml><?xml version="1.0" encoding="utf-8"?>
+<ds:datastoreItem xmlns:ds="http://schemas.openxmlformats.org/officeDocument/2006/customXml" ds:itemID="{01743C61-8CA7-48FF-B2A3-6055DA854CF6}">
+  <ds:schemaRefs>
+    <ds:schemaRef ds:uri="http://schemas.microsoft.com/sharepoint/v3/contenttype/forms"/>
+  </ds:schemaRefs>
+</ds:datastoreItem>
 </file>
 
-<file path=customXml/itemProps1.xml><?xml version="1.0" encoding="utf-8"?>
+<file path=customXml/itemProps3.xml><?xml version="1.0" encoding="utf-8"?>
 <ds:datastoreItem xmlns:ds="http://schemas.openxmlformats.org/officeDocument/2006/customXml" ds:itemID="{472965D8-9C19-4E48-8421-5D6B21FC440C}">
   <ds:schemaRefs>
     <ds:schemaRef ds:uri="http://schemas.microsoft.com/office/2006/metadata/contentType"/>
@@ -48396,22 +48562,4 @@
     <ds:schemaRef ds:uri="http://schemas.microsoft.com/internal/obd"/>
   </ds:schemaRefs>
 </ds:datastoreItem>
-</file>
-
-<file path=customXml/itemProps2.xml><?xml version="1.0" encoding="utf-8"?>
-<ds:datastoreItem xmlns:ds="http://schemas.openxmlformats.org/officeDocument/2006/customXml" ds:itemID="{01743C61-8CA7-48FF-B2A3-6055DA854CF6}">
-  <ds:schemaRefs>
-    <ds:schemaRef ds:uri="http://schemas.microsoft.com/sharepoint/v3/contenttype/forms"/>
-  </ds:schemaRefs>
-</ds:datastoreItem>
-</file>
-
-<file path=customXml/itemProps3.xml><?xml version="1.0" encoding="utf-8"?>
-<ds:datastoreItem xmlns:ds="http://schemas.openxmlformats.org/officeDocument/2006/customXml" ds:itemID="{D726A944-A9F4-4295-9B5E-C397EB1318B9}">
-  <ds:schemaRefs>
-    <ds:schemaRef ds:uri="http://schemas.microsoft.com/office/2006/metadata/properties"/>
-    <ds:schemaRef ds:uri="http://schemas.microsoft.com/office/infopath/2007/PartnerControls"/>
-    <ds:schemaRef ds:uri="71af3243-3dd4-4a8d-8c0d-dd76da1f02a5"/>
-  </ds:schemaRefs>
-</ds:datastoreItem>
 </file>
</xml_diff>